<commit_message>
Add orchestration notebook, update presentation, replace one-pager
- NB_06_Orchestration_v2: sequential pipeline runner using mssparkutils.notebook.run()
  with error handling and dependency enforcement (Bronze -> Silver -> Gold -> DQ)
- Slide 14 replaced: "Next Steps" -> "Why This Platform Delivers" — value proposition
  closing slide with three columns (Immediate Value, Structural Advantage, Risk Reduction)
- ACME_Architecture_OnePager: replaced DOCX with reviewed PDF version
- All dates updated to June 2026

Author: Diego Santiago Vieira de Brito
</commit_message>
<xml_diff>
--- a/docs/ACME_DE_POC_Presentation.pptx
+++ b/docs/ACME_DE_POC_Presentation.pptx
@@ -5922,14 +5922,14 @@
       </p:sp>
       <p:sp>
         <p:nvSpPr>
-          <p:cNvPr id="6" name="Text 4"/>
-          <p:cNvSpPr/>
-          <p:nvPr/>
-        </p:nvSpPr>
-        <p:spPr>
-          <a:xfrm>
-            <a:off x="457200" y="274320"/>
-            <a:ext cx="5486400" cy="548640"/>
+          <p:cNvPr id="6" name="Title"/>
+          <p:cNvSpPr/>
+          <p:nvPr/>
+        </p:nvSpPr>
+        <p:spPr>
+          <a:xfrm>
+            <a:off x="457200" y="228600"/>
+            <a:ext cx="6200000" cy="609600"/>
           </a:xfrm>
           <a:prstGeom prst="rect">
             <a:avLst/>
@@ -5945,55 +5945,27 @@
               <a:buNone/>
             </a:pPr>
             <a:r>
-              <a:rPr lang="en-US" sz="2600" b="1" dirty="0">
+              <a:rPr lang="en-US" sz="2800" b="1" dirty="0">
                 <a:solidFill>
                   <a:srgbClr val="FFFFFF"/>
                 </a:solidFill>
                 <a:latin typeface="Calibri" pitchFamily="34" charset="0"/>
-                <a:ea typeface="Calibri" pitchFamily="34" charset="-122"/>
-                <a:cs typeface="Calibri" pitchFamily="34" charset="-120"/>
-              </a:rPr>
-              <a:t>Next Steps</a:t>
-            </a:r>
-            <a:endParaRPr lang="en-US" sz="2600" dirty="0"/>
+              </a:rPr>
+              <a:t>Why This Platform Delivers</a:t>
+            </a:r>
           </a:p>
         </p:txBody>
       </p:sp>
       <p:sp>
         <p:nvSpPr>
-          <p:cNvPr id="7" name="Shape 5"/>
-          <p:cNvSpPr/>
-          <p:nvPr/>
-        </p:nvSpPr>
-        <p:spPr>
-          <a:xfrm>
-            <a:off x="457200" y="914400"/>
-            <a:ext cx="1371600" cy="621792"/>
-          </a:xfrm>
-          <a:prstGeom prst="rect">
-            <a:avLst/>
-          </a:prstGeom>
-          <a:solidFill>
-            <a:srgbClr val="C0392B"/>
-          </a:solidFill>
-          <a:ln w="12700">
-            <a:solidFill>
-              <a:srgbClr val="C0392B"/>
-            </a:solidFill>
-            <a:prstDash val="solid"/>
-          </a:ln>
-        </p:spPr>
-      </p:sp>
-      <p:sp>
-        <p:nvSpPr>
-          <p:cNvPr id="8" name="Text 6"/>
-          <p:cNvSpPr/>
-          <p:nvPr/>
-        </p:nvSpPr>
-        <p:spPr>
-          <a:xfrm>
-            <a:off x="457200" y="950976"/>
-            <a:ext cx="1371600" cy="548640"/>
+          <p:cNvPr id="7" name="Subtitle"/>
+          <p:cNvSpPr/>
+          <p:nvPr/>
+        </p:nvSpPr>
+        <p:spPr>
+          <a:xfrm>
+            <a:off x="457200" y="838200"/>
+            <a:ext cx="7600000" cy="304800"/>
           </a:xfrm>
           <a:prstGeom prst="rect">
             <a:avLst/>
@@ -6005,59 +5977,419 @@
           <a:bodyPr wrap="square" lIns="0" tIns="0" rIns="0" bIns="0" rtlCol="0" anchor="ctr"/>
           <a:lstStyle/>
           <a:p>
+            <a:pPr indent="0" marL="0">
+              <a:buNone/>
+            </a:pPr>
+            <a:r>
+              <a:rPr lang="en-US" sz="1200" i="1" dirty="0">
+                <a:solidFill>
+                  <a:srgbClr val="2DBD9E"/>
+                </a:solidFill>
+                <a:latin typeface="Calibri" pitchFamily="34" charset="0"/>
+              </a:rPr>
+              <a:t>From raw files to a governed, scalable analytics foundation — built to grow with the business.</a:t>
+            </a:r>
+          </a:p>
+        </p:txBody>
+      </p:sp>
+      <p:sp>
+        <p:nvSpPr>
+          <p:cNvPr id="8" name="Col1Header"/>
+          <p:cNvSpPr/>
+          <p:nvPr/>
+        </p:nvSpPr>
+        <p:spPr>
+          <a:xfrm>
+            <a:off x="457200" y="1219200"/>
+            <a:ext cx="2600000" cy="355600"/>
+          </a:xfrm>
+          <a:prstGeom prst="rect">
+            <a:avLst/>
+          </a:prstGeom>
+          <a:solidFill>
+            <a:srgbClr val="E8531A"/>
+          </a:solidFill>
+          <a:ln w="0">
+            <a:noFill/>
+          </a:ln>
+        </p:spPr>
+      </p:sp>
+      <p:sp>
+        <p:nvSpPr>
+          <p:cNvPr id="9" name="Col1HeaderText"/>
+          <p:cNvSpPr/>
+          <p:nvPr/>
+        </p:nvSpPr>
+        <p:spPr>
+          <a:xfrm>
+            <a:off x="457200" y="1219200"/>
+            <a:ext cx="2600000" cy="355600"/>
+          </a:xfrm>
+          <a:prstGeom prst="rect">
+            <a:avLst/>
+          </a:prstGeom>
+          <a:noFill/>
+          <a:ln/>
+        </p:spPr>
+        <p:txBody>
+          <a:bodyPr wrap="square" lIns="91440" tIns="0" rIns="91440" bIns="0" rtlCol="0" anchor="ctr"/>
+          <a:lstStyle/>
+          <a:p>
             <a:pPr algn="ctr" indent="0" marL="0">
               <a:buNone/>
             </a:pPr>
             <a:r>
-              <a:rPr lang="en-US" sz="1000" b="1" dirty="0">
-                <a:solidFill>
-                  <a:srgbClr val="1A1A1A"/>
-                </a:solidFill>
-                <a:latin typeface="Calibri" pitchFamily="34" charset="0"/>
-                <a:ea typeface="Calibri" pitchFamily="34" charset="-122"/>
-                <a:cs typeface="Calibri" pitchFamily="34" charset="-120"/>
-              </a:rPr>
-              <a:t>Weeks 1–2</a:t>
-            </a:r>
-            <a:endParaRPr lang="en-US" sz="1000" dirty="0"/>
+              <a:rPr lang="en-US" sz="1100" b="1" dirty="0">
+                <a:solidFill>
+                  <a:srgbClr val="FFFFFF"/>
+                </a:solidFill>
+                <a:latin typeface="Calibri" pitchFamily="34" charset="0"/>
+              </a:rPr>
+              <a:t>Immediate Value</a:t>
+            </a:r>
           </a:p>
         </p:txBody>
       </p:sp>
       <p:sp>
         <p:nvSpPr>
-          <p:cNvPr id="9" name="Shape 7"/>
-          <p:cNvSpPr/>
-          <p:nvPr/>
-        </p:nvSpPr>
-        <p:spPr>
-          <a:xfrm>
-            <a:off x="1920240" y="1207008"/>
-            <a:ext cx="4297680" cy="36576"/>
+          <p:cNvPr id="10" name="Col1Body"/>
+          <p:cNvSpPr/>
+          <p:nvPr/>
+        </p:nvSpPr>
+        <p:spPr>
+          <a:xfrm>
+            <a:off x="457200" y="1574800"/>
+            <a:ext cx="2600000" cy="2700000"/>
+          </a:xfrm>
+          <a:prstGeom prst="rect">
+            <a:avLst/>
+          </a:prstGeom>
+          <a:noFill/>
+          <a:ln/>
+        </p:spPr>
+        <p:txBody>
+          <a:bodyPr wrap="square" lIns="91440" tIns="91440" rIns="91440" bIns="91440" rtlCol="0" anchor="t"/>
+          <a:lstStyle/>
+          <a:p>
+            <a:pPr marL="228600" indent="-228600">
+              <a:buChar char="—"/>
+            </a:pPr>
+            <a:r>
+              <a:rPr lang="en-US" sz="900" dirty="0">
+                <a:solidFill>
+                  <a:srgbClr val="FFFFFF"/>
+                </a:solidFill>
+                <a:latin typeface="Calibri" pitchFamily="34" charset="0"/>
+              </a:rPr>
+              <a:t>Sales and margin visibility across all business dimensions — day one</a:t>
+            </a:r>
+          </a:p>
+          <a:p>
+            <a:pPr marL="228600" indent="-228600" spcBef="200000">
+              <a:buChar char="—"/>
+            </a:pPr>
+            <a:r>
+              <a:rPr lang="en-US" sz="900" dirty="0">
+                <a:solidFill>
+                  <a:srgbClr val="FFFFFF"/>
+                </a:solidFill>
+                <a:latin typeface="Calibri" pitchFamily="34" charset="0"/>
+              </a:rPr>
+              <a:t>Executive, product, and sales rep views from a single trusted model</a:t>
+            </a:r>
+          </a:p>
+          <a:p>
+            <a:pPr marL="228600" indent="-228600" spcBef="200000">
+              <a:buChar char="—"/>
+            </a:pPr>
+            <a:r>
+              <a:rPr lang="en-US" sz="900" dirty="0">
+                <a:solidFill>
+                  <a:srgbClr val="FFFFFF"/>
+                </a:solidFill>
+                <a:latin typeface="Calibri" pitchFamily="34" charset="0"/>
+              </a:rPr>
+              <a:t>Data quality issues surfaced and tracked, not hidden</a:t>
+            </a:r>
+          </a:p>
+        </p:txBody>
+      </p:sp>
+      <p:sp>
+        <p:nvSpPr>
+          <p:cNvPr id="11" name="Col2Header"/>
+          <p:cNvSpPr/>
+          <p:nvPr/>
+        </p:nvSpPr>
+        <p:spPr>
+          <a:xfrm>
+            <a:off x="3200000" y="1219200"/>
+            <a:ext cx="2600000" cy="355600"/>
           </a:xfrm>
           <a:prstGeom prst="rect">
             <a:avLst/>
           </a:prstGeom>
           <a:solidFill>
-            <a:srgbClr val="444444"/>
+            <a:srgbClr val="2251CC"/>
           </a:solidFill>
-          <a:ln w="12700">
-            <a:solidFill>
-              <a:srgbClr val="444444"/>
-            </a:solidFill>
-            <a:prstDash val="solid"/>
+          <a:ln w="0">
+            <a:noFill/>
           </a:ln>
         </p:spPr>
       </p:sp>
       <p:sp>
         <p:nvSpPr>
-          <p:cNvPr id="10" name="Text 8"/>
-          <p:cNvSpPr/>
-          <p:nvPr/>
-        </p:nvSpPr>
-        <p:spPr>
-          <a:xfrm>
-            <a:off x="2057400" y="914400"/>
-            <a:ext cx="4206240" cy="621792"/>
+          <p:cNvPr id="12" name="Col2HeaderText"/>
+          <p:cNvSpPr/>
+          <p:nvPr/>
+        </p:nvSpPr>
+        <p:spPr>
+          <a:xfrm>
+            <a:off x="3200000" y="1219200"/>
+            <a:ext cx="2600000" cy="355600"/>
+          </a:xfrm>
+          <a:prstGeom prst="rect">
+            <a:avLst/>
+          </a:prstGeom>
+          <a:noFill/>
+          <a:ln/>
+        </p:spPr>
+        <p:txBody>
+          <a:bodyPr wrap="square" lIns="91440" tIns="0" rIns="91440" bIns="0" rtlCol="0" anchor="ctr"/>
+          <a:lstStyle/>
+          <a:p>
+            <a:pPr algn="ctr" indent="0" marL="0">
+              <a:buNone/>
+            </a:pPr>
+            <a:r>
+              <a:rPr lang="en-US" sz="1100" b="1" dirty="0">
+                <a:solidFill>
+                  <a:srgbClr val="FFFFFF"/>
+                </a:solidFill>
+                <a:latin typeface="Calibri" pitchFamily="34" charset="0"/>
+              </a:rPr>
+              <a:t>Structural Advantage</a:t>
+            </a:r>
+          </a:p>
+        </p:txBody>
+      </p:sp>
+      <p:sp>
+        <p:nvSpPr>
+          <p:cNvPr id="13" name="Col2Body"/>
+          <p:cNvSpPr/>
+          <p:nvPr/>
+        </p:nvSpPr>
+        <p:spPr>
+          <a:xfrm>
+            <a:off x="3200000" y="1574800"/>
+            <a:ext cx="2600000" cy="2700000"/>
+          </a:xfrm>
+          <a:prstGeom prst="rect">
+            <a:avLst/>
+          </a:prstGeom>
+          <a:noFill/>
+          <a:ln/>
+        </p:spPr>
+        <p:txBody>
+          <a:bodyPr wrap="square" lIns="91440" tIns="91440" rIns="91440" bIns="91440" rtlCol="0" anchor="t"/>
+          <a:lstStyle/>
+          <a:p>
+            <a:pPr marL="228600" indent="-228600">
+              <a:buChar char="—"/>
+            </a:pPr>
+            <a:r>
+              <a:rPr lang="en-US" sz="900" dirty="0">
+                <a:solidFill>
+                  <a:srgbClr val="FFFFFF"/>
+                </a:solidFill>
+                <a:latin typeface="Calibri" pitchFamily="34" charset="0"/>
+              </a:rPr>
+              <a:t>Medallion architecture scales from POC to enterprise without re-architecture</a:t>
+            </a:r>
+          </a:p>
+          <a:p>
+            <a:pPr marL="228600" indent="-228600" spcBef="200000">
+              <a:buChar char="—"/>
+            </a:pPr>
+            <a:r>
+              <a:rPr lang="en-US" sz="900" dirty="0">
+                <a:solidFill>
+                  <a:srgbClr val="FFFFFF"/>
+                </a:solidFill>
+                <a:latin typeface="Calibri" pitchFamily="34" charset="0"/>
+              </a:rPr>
+              <a:t>Every layer is independently replaceable — no vendor lock-in at the data level</a:t>
+            </a:r>
+          </a:p>
+          <a:p>
+            <a:pPr marL="228600" indent="-228600" spcBef="200000">
+              <a:buChar char="—"/>
+            </a:pPr>
+            <a:r>
+              <a:rPr lang="en-US" sz="900" dirty="0">
+                <a:solidFill>
+                  <a:srgbClr val="FFFFFF"/>
+                </a:solidFill>
+                <a:latin typeface="Calibri" pitchFamily="34" charset="0"/>
+              </a:rPr>
+              <a:t>Direct Lake eliminates import latency — Power BI reads live from Delta</a:t>
+            </a:r>
+          </a:p>
+        </p:txBody>
+      </p:sp>
+      <p:sp>
+        <p:nvSpPr>
+          <p:cNvPr id="14" name="Col3Header"/>
+          <p:cNvSpPr/>
+          <p:nvPr/>
+        </p:nvSpPr>
+        <p:spPr>
+          <a:xfrm>
+            <a:off x="5943000" y="1219200"/>
+            <a:ext cx="2600000" cy="355600"/>
+          </a:xfrm>
+          <a:prstGeom prst="rect">
+            <a:avLst/>
+          </a:prstGeom>
+          <a:solidFill>
+            <a:srgbClr val="2DBD9E"/>
+          </a:solidFill>
+          <a:ln w="0">
+            <a:noFill/>
+          </a:ln>
+        </p:spPr>
+      </p:sp>
+      <p:sp>
+        <p:nvSpPr>
+          <p:cNvPr id="15" name="Col3HeaderText"/>
+          <p:cNvSpPr/>
+          <p:nvPr/>
+        </p:nvSpPr>
+        <p:spPr>
+          <a:xfrm>
+            <a:off x="5943000" y="1219200"/>
+            <a:ext cx="2600000" cy="355600"/>
+          </a:xfrm>
+          <a:prstGeom prst="rect">
+            <a:avLst/>
+          </a:prstGeom>
+          <a:noFill/>
+          <a:ln/>
+        </p:spPr>
+        <p:txBody>
+          <a:bodyPr wrap="square" lIns="91440" tIns="0" rIns="91440" bIns="0" rtlCol="0" anchor="ctr"/>
+          <a:lstStyle/>
+          <a:p>
+            <a:pPr algn="ctr" indent="0" marL="0">
+              <a:buNone/>
+            </a:pPr>
+            <a:r>
+              <a:rPr lang="en-US" sz="1100" b="1" dirty="0">
+                <a:solidFill>
+                  <a:srgbClr val="FFFFFF"/>
+                </a:solidFill>
+                <a:latin typeface="Calibri" pitchFamily="34" charset="0"/>
+              </a:rPr>
+              <a:t>Risk Reduction</a:t>
+            </a:r>
+          </a:p>
+        </p:txBody>
+      </p:sp>
+      <p:sp>
+        <p:nvSpPr>
+          <p:cNvPr id="16" name="Col3Body"/>
+          <p:cNvSpPr/>
+          <p:nvPr/>
+        </p:nvSpPr>
+        <p:spPr>
+          <a:xfrm>
+            <a:off x="5943000" y="1574800"/>
+            <a:ext cx="2600000" cy="2700000"/>
+          </a:xfrm>
+          <a:prstGeom prst="rect">
+            <a:avLst/>
+          </a:prstGeom>
+          <a:noFill/>
+          <a:ln/>
+        </p:spPr>
+        <p:txBody>
+          <a:bodyPr wrap="square" lIns="91440" tIns="91440" rIns="91440" bIns="91440" rtlCol="0" anchor="t"/>
+          <a:lstStyle/>
+          <a:p>
+            <a:pPr marL="228600" indent="-228600">
+              <a:buChar char="—"/>
+            </a:pPr>
+            <a:r>
+              <a:rPr lang="en-US" sz="900" dirty="0">
+                <a:solidFill>
+                  <a:srgbClr val="FFFFFF"/>
+                </a:solidFill>
+                <a:latin typeface="Calibri" pitchFamily="34" charset="0"/>
+              </a:rPr>
+              <a:t>Bronze layer preserves source data immutably — full audit trail from day one</a:t>
+            </a:r>
+          </a:p>
+          <a:p>
+            <a:pPr marL="228600" indent="-228600" spcBef="200000">
+              <a:buChar char="—"/>
+            </a:pPr>
+            <a:r>
+              <a:rPr lang="en-US" sz="900" dirty="0">
+                <a:solidFill>
+                  <a:srgbClr val="FFFFFF"/>
+                </a:solidFill>
+                <a:latin typeface="Calibri" pitchFamily="34" charset="0"/>
+              </a:rPr>
+              <a:t>Quarantine framework makes data quality failures visible and governable</a:t>
+            </a:r>
+          </a:p>
+          <a:p>
+            <a:pPr marL="228600" indent="-228600" spcBef="200000">
+              <a:buChar char="—"/>
+            </a:pPr>
+            <a:r>
+              <a:rPr lang="en-US" sz="900" dirty="0">
+                <a:solidFill>
+                  <a:srgbClr val="FFFFFF"/>
+                </a:solidFill>
+                <a:latin typeface="Calibri" pitchFamily="34" charset="0"/>
+              </a:rPr>
+              <a:t>Unknown Members and referential integrity protect financial figures from orphaned records</a:t>
+            </a:r>
+          </a:p>
+        </p:txBody>
+      </p:sp>
+      <p:sp>
+        <p:nvSpPr>
+          <p:cNvPr id="17" name="BannerBg"/>
+          <p:cNvSpPr/>
+          <p:nvPr/>
+        </p:nvSpPr>
+        <p:spPr>
+          <a:xfrm>
+            <a:off x="0" y="4434840"/>
+            <a:ext cx="9144000" cy="500000"/>
+          </a:xfrm>
+          <a:prstGeom prst="rect">
+            <a:avLst/>
+          </a:prstGeom>
+          <a:solidFill>
+            <a:srgbClr val="E8531A"/>
+          </a:solidFill>
+          <a:ln w="0">
+            <a:noFill/>
+          </a:ln>
+        </p:spPr>
+      </p:sp>
+      <p:sp>
+        <p:nvSpPr>
+          <p:cNvPr id="18" name="BannerText"/>
+          <p:cNvSpPr/>
+          <p:nvPr/>
+        </p:nvSpPr>
+        <p:spPr>
+          <a:xfrm>
+            <a:off x="274320" y="4434840"/>
+            <a:ext cx="8595360" cy="500000"/>
           </a:xfrm>
           <a:prstGeom prst="rect">
             <a:avLst/>
@@ -6069,59 +6401,31 @@
           <a:bodyPr wrap="square" lIns="0" tIns="0" rIns="0" bIns="0" rtlCol="0" anchor="ctr"/>
           <a:lstStyle/>
           <a:p>
-            <a:pPr algn="l" indent="0" marL="0">
+            <a:pPr algn="ctr" indent="0" marL="0">
               <a:buNone/>
             </a:pPr>
             <a:r>
-              <a:rPr lang="en-US" sz="1100" dirty="0">
+              <a:rPr lang="en-US" sz="1100" b="1" dirty="0">
                 <a:solidFill>
                   <a:srgbClr val="FFFFFF"/>
                 </a:solidFill>
                 <a:latin typeface="Calibri" pitchFamily="34" charset="0"/>
-                <a:ea typeface="Calibri" pitchFamily="34" charset="-122"/>
-                <a:cs typeface="Calibri" pitchFamily="34" charset="-120"/>
-              </a:rPr>
-              <a:t>Fix source data issues (DivisionID, Shippers, Logistics alignment)</a:t>
-            </a:r>
-            <a:endParaRPr lang="en-US" sz="1100" dirty="0"/>
+              </a:rPr>
+              <a:t>The foundation is built. The business questions are answered. What happens next is a business decision.</a:t>
+            </a:r>
           </a:p>
         </p:txBody>
       </p:sp>
       <p:sp>
         <p:nvSpPr>
-          <p:cNvPr id="11" name="Shape 9"/>
-          <p:cNvSpPr/>
-          <p:nvPr/>
-        </p:nvSpPr>
-        <p:spPr>
-          <a:xfrm>
-            <a:off x="457200" y="1783080"/>
-            <a:ext cx="1371600" cy="621792"/>
-          </a:xfrm>
-          <a:prstGeom prst="rect">
-            <a:avLst/>
-          </a:prstGeom>
-          <a:solidFill>
-            <a:srgbClr val="E8531A"/>
-          </a:solidFill>
-          <a:ln w="12700">
-            <a:solidFill>
-              <a:srgbClr val="E8531A"/>
-            </a:solidFill>
-            <a:prstDash val="solid"/>
-          </a:ln>
-        </p:spPr>
-      </p:sp>
-      <p:sp>
-        <p:nvSpPr>
-          <p:cNvPr id="12" name="Text 10"/>
-          <p:cNvSpPr/>
-          <p:nvPr/>
-        </p:nvSpPr>
-        <p:spPr>
-          <a:xfrm>
-            <a:off x="457200" y="1819656"/>
-            <a:ext cx="1371600" cy="548640"/>
+          <p:cNvPr id="19" name="Footer"/>
+          <p:cNvSpPr/>
+          <p:nvPr/>
+        </p:nvSpPr>
+        <p:spPr>
+          <a:xfrm>
+            <a:off x="0" y="4934840"/>
+            <a:ext cx="9144000" cy="208660"/>
           </a:xfrm>
           <a:prstGeom prst="rect">
             <a:avLst/>
@@ -6137,401 +6441,14 @@
               <a:buNone/>
             </a:pPr>
             <a:r>
-              <a:rPr lang="en-US" sz="1000" b="1" dirty="0">
-                <a:solidFill>
-                  <a:srgbClr val="1A1A1A"/>
-                </a:solidFill>
-                <a:latin typeface="Calibri" pitchFamily="34" charset="0"/>
-                <a:ea typeface="Calibri" pitchFamily="34" charset="-122"/>
-                <a:cs typeface="Calibri" pitchFamily="34" charset="-120"/>
-              </a:rPr>
-              <a:t>Sprint 2</a:t>
-            </a:r>
-            <a:endParaRPr lang="en-US" sz="1000" dirty="0"/>
-          </a:p>
-        </p:txBody>
-      </p:sp>
-      <p:sp>
-        <p:nvSpPr>
-          <p:cNvPr id="13" name="Shape 11"/>
-          <p:cNvSpPr/>
-          <p:nvPr/>
-        </p:nvSpPr>
-        <p:spPr>
-          <a:xfrm>
-            <a:off x="1920240" y="2075688"/>
-            <a:ext cx="4297680" cy="36576"/>
-          </a:xfrm>
-          <a:prstGeom prst="rect">
-            <a:avLst/>
-          </a:prstGeom>
-          <a:solidFill>
-            <a:srgbClr val="444444"/>
-          </a:solidFill>
-          <a:ln w="12700">
-            <a:solidFill>
-              <a:srgbClr val="444444"/>
-            </a:solidFill>
-            <a:prstDash val="solid"/>
-          </a:ln>
-        </p:spPr>
-      </p:sp>
-      <p:sp>
-        <p:nvSpPr>
-          <p:cNvPr id="14" name="Text 12"/>
-          <p:cNvSpPr/>
-          <p:nvPr/>
-        </p:nvSpPr>
-        <p:spPr>
-          <a:xfrm>
-            <a:off x="2057400" y="1783080"/>
-            <a:ext cx="4206240" cy="621792"/>
-          </a:xfrm>
-          <a:prstGeom prst="rect">
-            <a:avLst/>
-          </a:prstGeom>
-          <a:noFill/>
-          <a:ln/>
-        </p:spPr>
-        <p:txBody>
-          <a:bodyPr wrap="square" lIns="0" tIns="0" rIns="0" bIns="0" rtlCol="0" anchor="ctr"/>
-          <a:lstStyle/>
-          <a:p>
-            <a:pPr algn="l" indent="0" marL="0">
-              <a:buNone/>
-            </a:pPr>
-            <a:r>
-              <a:rPr lang="en-US" sz="1100" dirty="0">
-                <a:solidFill>
-                  <a:srgbClr val="FFFFFF"/>
-                </a:solidFill>
-                <a:latin typeface="Calibri" pitchFamily="34" charset="0"/>
-                <a:ea typeface="Calibri" pitchFamily="34" charset="-122"/>
-                <a:cs typeface="Calibri" pitchFamily="34" charset="-120"/>
-              </a:rPr>
-              <a:t>SCD Type 2 on Products — current Shipments integration</a:t>
-            </a:r>
-            <a:endParaRPr lang="en-US" sz="1100" dirty="0"/>
-          </a:p>
-        </p:txBody>
-      </p:sp>
-      <p:sp>
-        <p:nvSpPr>
-          <p:cNvPr id="15" name="Shape 13"/>
-          <p:cNvSpPr/>
-          <p:nvPr/>
-        </p:nvSpPr>
-        <p:spPr>
-          <a:xfrm>
-            <a:off x="457200" y="2651760"/>
-            <a:ext cx="1371600" cy="621792"/>
-          </a:xfrm>
-          <a:prstGeom prst="rect">
-            <a:avLst/>
-          </a:prstGeom>
-          <a:solidFill>
-            <a:srgbClr val="F5A623"/>
-          </a:solidFill>
-          <a:ln w="12700">
-            <a:solidFill>
-              <a:srgbClr val="F5A623"/>
-            </a:solidFill>
-            <a:prstDash val="solid"/>
-          </a:ln>
-        </p:spPr>
-      </p:sp>
-      <p:sp>
-        <p:nvSpPr>
-          <p:cNvPr id="16" name="Text 14"/>
-          <p:cNvSpPr/>
-          <p:nvPr/>
-        </p:nvSpPr>
-        <p:spPr>
-          <a:xfrm>
-            <a:off x="457200" y="2688336"/>
-            <a:ext cx="1371600" cy="548640"/>
-          </a:xfrm>
-          <a:prstGeom prst="rect">
-            <a:avLst/>
-          </a:prstGeom>
-          <a:noFill/>
-          <a:ln/>
-        </p:spPr>
-        <p:txBody>
-          <a:bodyPr wrap="square" lIns="0" tIns="0" rIns="0" bIns="0" rtlCol="0" anchor="ctr"/>
-          <a:lstStyle/>
-          <a:p>
-            <a:pPr algn="ctr" indent="0" marL="0">
-              <a:buNone/>
-            </a:pPr>
-            <a:r>
-              <a:rPr lang="en-US" sz="1000" b="1" dirty="0">
-                <a:solidFill>
-                  <a:srgbClr val="1A1A1A"/>
-                </a:solidFill>
-                <a:latin typeface="Calibri" pitchFamily="34" charset="0"/>
-                <a:ea typeface="Calibri" pitchFamily="34" charset="-122"/>
-                <a:cs typeface="Calibri" pitchFamily="34" charset="-120"/>
-              </a:rPr>
-              <a:t>Sprint 3</a:t>
-            </a:r>
-            <a:endParaRPr lang="en-US" sz="1000" dirty="0"/>
-          </a:p>
-        </p:txBody>
-      </p:sp>
-      <p:sp>
-        <p:nvSpPr>
-          <p:cNvPr id="17" name="Shape 15"/>
-          <p:cNvSpPr/>
-          <p:nvPr/>
-        </p:nvSpPr>
-        <p:spPr>
-          <a:xfrm>
-            <a:off x="1920240" y="2944368"/>
-            <a:ext cx="4297680" cy="36576"/>
-          </a:xfrm>
-          <a:prstGeom prst="rect">
-            <a:avLst/>
-          </a:prstGeom>
-          <a:solidFill>
-            <a:srgbClr val="444444"/>
-          </a:solidFill>
-          <a:ln w="12700">
-            <a:solidFill>
-              <a:srgbClr val="444444"/>
-            </a:solidFill>
-            <a:prstDash val="solid"/>
-          </a:ln>
-        </p:spPr>
-      </p:sp>
-      <p:sp>
-        <p:nvSpPr>
-          <p:cNvPr id="18" name="Text 16"/>
-          <p:cNvSpPr/>
-          <p:nvPr/>
-        </p:nvSpPr>
-        <p:spPr>
-          <a:xfrm>
-            <a:off x="2057400" y="2651760"/>
-            <a:ext cx="4206240" cy="621792"/>
-          </a:xfrm>
-          <a:prstGeom prst="rect">
-            <a:avLst/>
-          </a:prstGeom>
-          <a:noFill/>
-          <a:ln/>
-        </p:spPr>
-        <p:txBody>
-          <a:bodyPr wrap="square" lIns="0" tIns="0" rIns="0" bIns="0" rtlCol="0" anchor="ctr"/>
-          <a:lstStyle/>
-          <a:p>
-            <a:pPr algn="l" indent="0" marL="0">
-              <a:buNone/>
-            </a:pPr>
-            <a:r>
-              <a:rPr lang="en-US" sz="1100" dirty="0">
-                <a:solidFill>
-                  <a:srgbClr val="FFFFFF"/>
-                </a:solidFill>
-                <a:latin typeface="Calibri" pitchFamily="34" charset="0"/>
-                <a:ea typeface="Calibri" pitchFamily="34" charset="-122"/>
-                <a:cs typeface="Calibri" pitchFamily="34" charset="-120"/>
-              </a:rPr>
-              <a:t>Incremental pipeline, quarantine alerting, production handoff</a:t>
-            </a:r>
-            <a:endParaRPr lang="en-US" sz="1100" dirty="0"/>
-          </a:p>
-        </p:txBody>
-      </p:sp>
-      <p:sp>
-        <p:nvSpPr>
-          <p:cNvPr id="19" name="Shape 17"/>
-          <p:cNvSpPr/>
-          <p:nvPr/>
-        </p:nvSpPr>
-        <p:spPr>
-          <a:xfrm>
-            <a:off x="457200" y="3520440"/>
-            <a:ext cx="1371600" cy="621792"/>
-          </a:xfrm>
-          <a:prstGeom prst="rect">
-            <a:avLst/>
-          </a:prstGeom>
-          <a:solidFill>
-            <a:srgbClr val="2DBD9E"/>
-          </a:solidFill>
-          <a:ln w="12700">
-            <a:solidFill>
-              <a:srgbClr val="2DBD9E"/>
-            </a:solidFill>
-            <a:prstDash val="solid"/>
-          </a:ln>
-        </p:spPr>
-      </p:sp>
-      <p:sp>
-        <p:nvSpPr>
-          <p:cNvPr id="20" name="Text 18"/>
-          <p:cNvSpPr/>
-          <p:nvPr/>
-        </p:nvSpPr>
-        <p:spPr>
-          <a:xfrm>
-            <a:off x="457200" y="3557016"/>
-            <a:ext cx="1371600" cy="548640"/>
-          </a:xfrm>
-          <a:prstGeom prst="rect">
-            <a:avLst/>
-          </a:prstGeom>
-          <a:noFill/>
-          <a:ln/>
-        </p:spPr>
-        <p:txBody>
-          <a:bodyPr wrap="square" lIns="0" tIns="0" rIns="0" bIns="0" rtlCol="0" anchor="ctr"/>
-          <a:lstStyle/>
-          <a:p>
-            <a:pPr algn="ctr" indent="0" marL="0">
-              <a:buNone/>
-            </a:pPr>
-            <a:r>
-              <a:rPr lang="en-US" sz="1000" b="1" dirty="0">
-                <a:solidFill>
-                  <a:srgbClr val="1A1A1A"/>
-                </a:solidFill>
-                <a:latin typeface="Calibri" pitchFamily="34" charset="0"/>
-                <a:ea typeface="Calibri" pitchFamily="34" charset="-122"/>
-                <a:cs typeface="Calibri" pitchFamily="34" charset="-120"/>
-              </a:rPr>
-              <a:t>Q3 2021</a:t>
-            </a:r>
-            <a:endParaRPr lang="en-US" sz="1000" dirty="0"/>
-          </a:p>
-        </p:txBody>
-      </p:sp>
-      <p:sp>
-        <p:nvSpPr>
-          <p:cNvPr id="21" name="Shape 19"/>
-          <p:cNvSpPr/>
-          <p:nvPr/>
-        </p:nvSpPr>
-        <p:spPr>
-          <a:xfrm>
-            <a:off x="1920240" y="3813048"/>
-            <a:ext cx="4297680" cy="36576"/>
-          </a:xfrm>
-          <a:prstGeom prst="rect">
-            <a:avLst/>
-          </a:prstGeom>
-          <a:solidFill>
-            <a:srgbClr val="444444"/>
-          </a:solidFill>
-          <a:ln w="12700">
-            <a:solidFill>
-              <a:srgbClr val="444444"/>
-            </a:solidFill>
-            <a:prstDash val="solid"/>
-          </a:ln>
-        </p:spPr>
-      </p:sp>
-      <p:sp>
-        <p:nvSpPr>
-          <p:cNvPr id="22" name="Text 20"/>
-          <p:cNvSpPr/>
-          <p:nvPr/>
-        </p:nvSpPr>
-        <p:spPr>
-          <a:xfrm>
-            <a:off x="2057400" y="3520440"/>
-            <a:ext cx="4206240" cy="621792"/>
-          </a:xfrm>
-          <a:prstGeom prst="rect">
-            <a:avLst/>
-          </a:prstGeom>
-          <a:noFill/>
-          <a:ln/>
-        </p:spPr>
-        <p:txBody>
-          <a:bodyPr wrap="square" lIns="0" tIns="0" rIns="0" bIns="0" rtlCol="0" anchor="ctr"/>
-          <a:lstStyle/>
-          <a:p>
-            <a:pPr algn="l" indent="0" marL="0">
-              <a:buNone/>
-            </a:pPr>
-            <a:r>
-              <a:rPr lang="en-US" sz="1100" dirty="0">
-                <a:solidFill>
-                  <a:srgbClr val="FFFFFF"/>
-                </a:solidFill>
-                <a:latin typeface="Calibri" pitchFamily="34" charset="0"/>
-                <a:ea typeface="Calibri" pitchFamily="34" charset="-122"/>
-                <a:cs typeface="Calibri" pitchFamily="34" charset="-120"/>
-              </a:rPr>
-              <a:t>Full Power BI rollout — executives, product managers, sales reps</a:t>
-            </a:r>
-            <a:endParaRPr lang="en-US" sz="1100" dirty="0"/>
-          </a:p>
-        </p:txBody>
-      </p:sp>
-      <p:sp>
-        <p:nvSpPr>
-          <p:cNvPr id="23" name="Shape 21"/>
-          <p:cNvSpPr/>
-          <p:nvPr/>
-        </p:nvSpPr>
-        <p:spPr>
-          <a:xfrm>
-            <a:off x="0" y="4434840"/>
-            <a:ext cx="9144000" cy="708660"/>
-          </a:xfrm>
-          <a:prstGeom prst="rect">
-            <a:avLst/>
-          </a:prstGeom>
-          <a:solidFill>
-            <a:srgbClr val="E8531A"/>
-          </a:solidFill>
-          <a:ln w="12700">
-            <a:solidFill>
-              <a:srgbClr val="E8531A"/>
-            </a:solidFill>
-            <a:prstDash val="solid"/>
-          </a:ln>
-        </p:spPr>
-      </p:sp>
-      <p:sp>
-        <p:nvSpPr>
-          <p:cNvPr id="24" name="Text 22"/>
-          <p:cNvSpPr/>
-          <p:nvPr/>
-        </p:nvSpPr>
-        <p:spPr>
-          <a:xfrm>
-            <a:off x="274320" y="4498848"/>
-            <a:ext cx="8595360" cy="566928"/>
-          </a:xfrm>
-          <a:prstGeom prst="rect">
-            <a:avLst/>
-          </a:prstGeom>
-          <a:noFill/>
-          <a:ln/>
-        </p:spPr>
-        <p:txBody>
-          <a:bodyPr wrap="square" lIns="0" tIns="0" rIns="0" bIns="0" rtlCol="0" anchor="ctr"/>
-          <a:lstStyle/>
-          <a:p>
-            <a:pPr algn="ctr" indent="0" marL="0">
-              <a:buNone/>
-            </a:pPr>
-            <a:r>
-              <a:rPr lang="en-US" sz="1400" b="1" dirty="0">
-                <a:solidFill>
-                  <a:srgbClr val="FFFFFF"/>
-                </a:solidFill>
-                <a:latin typeface="Calibri" pitchFamily="34" charset="0"/>
-                <a:ea typeface="Calibri" pitchFamily="34" charset="-122"/>
-                <a:cs typeface="Calibri" pitchFamily="34" charset="-120"/>
-              </a:rPr>
-              <a:t>pomerol  ·  We simplify data to help businesses grow.</a:t>
-            </a:r>
-            <a:endParaRPr lang="en-US" sz="1400" dirty="0"/>
+              <a:rPr lang="en-US" sz="800" dirty="0">
+                <a:solidFill>
+                  <a:srgbClr val="888888"/>
+                </a:solidFill>
+                <a:latin typeface="Calibri" pitchFamily="34" charset="0"/>
+              </a:rPr>
+              <a:t>Diego Santiago Vieira de Brito  |  June 2026</a:t>
+            </a:r>
           </a:p>
         </p:txBody>
       </p:sp>

</xml_diff>

<commit_message>
fix: DQ check count 9→10 on slide 15, typo+weak closing statement on slide 17
</commit_message>
<xml_diff>
--- a/docs/ACME_DE_POC_Presentation.pptx
+++ b/docs/ACME_DE_POC_Presentation.pptx
@@ -8390,7 +8390,7 @@
                 </a:solidFill>
                 <a:latin typeface="Calibri"/>
               </a:rPr>
-              <a:t>9 data quality checks across all layers. Results published to Power BI governance page.</a:t>
+              <a:t>10 data quality checks across all layers. Results published to Power BI governance page.</a:t>
             </a:r>
           </a:p>
         </p:txBody>
@@ -11480,7 +11480,7 @@
                 </a:solidFill>
                 <a:latin typeface="Calibri"/>
               </a:rPr>
-              <a:t>The foundation is built. The business questions are answered. What happens next is a </a:t>
+              <a:t>The foundation is built. The business questions are answered. What happens next is a business decision.</a:t>
             </a:r>
             <a:r>
               <a:rPr lang="en-US" sz="1100" b="0" i="1" dirty="0">
@@ -11489,7 +11489,7 @@
                 </a:solidFill>
                 <a:latin typeface="Calibri"/>
               </a:rPr>
-              <a:t>data oriented </a:t>
+              <a:t/>
             </a:r>
             <a:r>
               <a:rPr sz="1100" b="0" i="1" dirty="0">
@@ -11498,7 +11498,7 @@
                 </a:solidFill>
                 <a:latin typeface="Calibri"/>
               </a:rPr>
-              <a:t>business </a:t>
+              <a:t/>
             </a:r>
             <a:r>
               <a:rPr lang="en-US" sz="1100" b="0" i="1" dirty="0" err="1">
@@ -11507,7 +11507,7 @@
                 </a:solidFill>
                 <a:latin typeface="Calibri"/>
               </a:rPr>
-              <a:t>enviroment</a:t>
+              <a:t/>
             </a:r>
             <a:r>
               <a:rPr sz="1100" b="0" i="1" dirty="0">
@@ -11516,7 +11516,7 @@
                 </a:solidFill>
                 <a:latin typeface="Calibri"/>
               </a:rPr>
-              <a:t>.</a:t>
+              <a:t/>
             </a:r>
           </a:p>
         </p:txBody>

</xml_diff>